<commit_message>
refactor: update presentation text, layout parameters, and dataset distribution statistics while cleaning up project presentation files.
</commit_message>
<xml_diff>
--- a/Medical_Specialty_Classification_First_Presentation.pptx
+++ b/Medical_Specialty_Classification_First_Presentation.pptx
@@ -4521,7 +4521,7 @@
               </a:defRPr>
             </a:pPr>
             <a:r>
-              <a:t>•  Formulation: Identifies optimal separating hyperplanes maximizing the functional margin between specialty classes.</a:t>
+              <a:t>•  Formulation: Constructs optimal decision boundaries by maximizing the margin between different medical specialty classes.</a:t>
             </a:r>
           </a:p>
           <a:p>
@@ -4536,7 +4536,7 @@
               </a:defRPr>
             </a:pPr>
             <a:r>
-              <a:t>•  Sparse Vector Superiority: Consistently recognized in clinical NLP literature as a top performer for text classification.</a:t>
+              <a:t>•  Sparse Vector Superiority: Consistently recognized in clinical NLP literature as a top performer for high-dimensional text classification.</a:t>
             </a:r>
           </a:p>
           <a:p>
@@ -4866,7 +4866,7 @@
               </a:defRPr>
             </a:pPr>
             <a:r>
-              <a:t>PROBABILISTIC WORD-FREQUENCY MODEL</a:t>
+              <a:t>PROBABILISTIC FEATURE MODEL</a:t>
             </a:r>
           </a:p>
           <a:p>
@@ -4881,7 +4881,7 @@
               </a:defRPr>
             </a:pPr>
             <a:r>
-              <a:t>•  Formulation: Applies Bayes' theorem with independence assumptions tailored for discrete term frequency vectors.</a:t>
+              <a:t>•  Formulation: Applies Bayes' theorem with conditional feature independence to compute posterior class probabilities.</a:t>
             </a:r>
           </a:p>
           <a:p>
@@ -4896,7 +4896,7 @@
               </a:defRPr>
             </a:pPr>
             <a:r>
-              <a:t>•  Laplace Smoothing: Handles zero-probability terms for unobserved medical tokens in test transcriptions.</a:t>
+              <a:t>•  Feature Compatibility: Effectively handles non-negative TF-IDF feature representations for probabilistic text classification.</a:t>
             </a:r>
           </a:p>
           <a:p>
@@ -4911,7 +4911,7 @@
               </a:defRPr>
             </a:pPr>
             <a:r>
-              <a:t>•  Computational Efficiency: Exceptionally lightweight and rapid, providing diverse complementary probabilities.</a:t>
+              <a:t>•  Laplace Smoothing: Handles zero-probability terms for unobserved medical tokens in test transcriptions.</a:t>
             </a:r>
           </a:p>
         </p:txBody>
@@ -5415,7 +5415,7 @@
               </a:defRPr>
             </a:pPr>
             <a:r>
-              <a:t>SVM</a:t>
+              <a:t>Calibrated SVM</a:t>
             </a:r>
           </a:p>
         </p:txBody>
@@ -5751,7 +5751,7 @@
             </a:r>
             <a:br/>
             <a:r>
-              <a:t>Weighted / Average Pooling</a:t>
+              <a:t>Average Probability Aggregation</a:t>
             </a:r>
             <a:br/>
             <a:r>
@@ -5989,7 +5989,7 @@
               </a:defRPr>
             </a:pPr>
             <a:r>
-              <a:t>•  Probability Granularity: Hard voting counts binary majority votes, ignoring confidence. Soft voting sums class probabilities.</a:t>
+              <a:t>•  Probability Granularity: Hard voting counts binary majority votes, ignoring confidence. Soft voting averages class probability distributions.</a:t>
             </a:r>
           </a:p>
           <a:p>
@@ -6004,7 +6004,7 @@
               </a:defRPr>
             </a:pPr>
             <a:r>
-              <a:t>•  Weighting Subtle Signals: If an ambiguous clinical note gives 49% probability to Neurology across models, soft voting preserves that critical confidence gradient.</a:t>
+              <a:t>•  Preserves Subtle Confidence: Ambiguous clinical notes yield smooth probability distributions rather than abrupt majority deadlocks.</a:t>
             </a:r>
           </a:p>
           <a:p>
@@ -6019,7 +6019,7 @@
               </a:defRPr>
             </a:pPr>
             <a:r>
-              <a:t>•  Reduced Misclassification: Mitigates abrupt decision boundary errors common in single-vote deadlocks.</a:t>
+              <a:t>•  Reduced Misclassification: Leverages agreement across diverse inductive biases to reduce individual classifier variance.</a:t>
             </a:r>
           </a:p>
         </p:txBody>
@@ -6172,7 +6172,7 @@
               </a:defRPr>
             </a:pPr>
             <a:r>
-              <a:t>•  It learns decision boundaries between different medical specialty categories using the TF-IDF feature representation.</a:t>
+              <a:t>•  Probability calibration enables the SVM classifier to contribute class probability estimates to the soft-voting ensemble.</a:t>
             </a:r>
           </a:p>
           <a:p>
@@ -6187,7 +6187,7 @@
               </a:defRPr>
             </a:pPr>
             <a:r>
-              <a:t>•  Its predictions contribute to the overall ensemble decision together with Random Forest, Logistic Regression, and Multinomial Naive Bayes.</a:t>
+              <a:t>•  It learns decision boundaries between different medical specialty categories using the TF-IDF feature representation.</a:t>
             </a:r>
           </a:p>
         </p:txBody>
@@ -6325,7 +6325,7 @@
               </a:defRPr>
             </a:pPr>
             <a:r>
-              <a:t>•  Bias-Variance Trade-off: Combines linear hyperplanes (SVM, LR) with tree-based partitioning (RF) and probabilistic priors (MNB).</a:t>
+              <a:t>•  Bias-Variance Trade-off: Combines linear hyperplanes (SVM, LR) with tree partitioning (RF) and probabilistic priors (MNB) to reduce prediction variance.</a:t>
             </a:r>
           </a:p>
           <a:p>
@@ -6340,7 +6340,7 @@
               </a:defRPr>
             </a:pPr>
             <a:r>
-              <a:t>•  Minority Specialty Sensitivity: Improves recognition rates on under-represented medical classes with fewer training notes.</a:t>
+              <a:t>•  Minority Specialty Sensitivity: Potentially improves recognition of under-represented medical classes with fewer training notes.</a:t>
             </a:r>
           </a:p>
           <a:p>
@@ -6355,7 +6355,7 @@
               </a:defRPr>
             </a:pPr>
             <a:r>
-              <a:t>•  Production Reliability: Ensures robust, dependable inference before serializing the pipeline for Flask web serving.</a:t>
+              <a:t>•  Production Reliability: Is expected to deliver robust, dependable inference prior to serializing the pipeline for Flask web serving.</a:t>
             </a:r>
           </a:p>
         </p:txBody>
@@ -6856,7 +6856,7 @@
               </a:defRPr>
             </a:pPr>
             <a:r>
-              <a:t>•  Text Preprocessing: Lowercasing, medical stop-word filtering, WordNet lemmatization.</a:t>
+              <a:t>•  Text Preprocessing: Lowercasing, character cleaning, stop-word removal, and WordNet lemmatization.</a:t>
             </a:r>
           </a:p>
           <a:p>
@@ -6871,7 +6871,7 @@
               </a:defRPr>
             </a:pPr>
             <a:r>
-              <a:t>•  TF-IDF Vectorization: Unigram &amp; bigram features with sublinear scaling (features_final.csv).</a:t>
+              <a:t>•  TF-IDF Vectorization: Unigram and bigram features with sublinear scaling transformed into a sparse numerical feature matrix.</a:t>
             </a:r>
           </a:p>
         </p:txBody>
@@ -7024,7 +7024,7 @@
               </a:defRPr>
             </a:pPr>
             <a:r>
-              <a:t>•  Parallel Training: SVM (calibrated), Random Forest, Logistic Regression, Multinomial Naive Bayes.</a:t>
+              <a:t>•  Parallel Training: Calibrated SVM, Random Forest, Logistic Regression, and Multinomial Naive Bayes.</a:t>
             </a:r>
           </a:p>
           <a:p>
@@ -7039,7 +7039,7 @@
               </a:defRPr>
             </a:pPr>
             <a:r>
-              <a:t>•  Soft Voting Ensemble: Synthesizes probability consensus, evaluated via multi-class metrics &amp; serialized.</a:t>
+              <a:t>•  Soft Voting Ensemble: Synthesizes probability consensus via average pooling; evaluated across multi-class metrics.</a:t>
             </a:r>
           </a:p>
         </p:txBody>
@@ -7177,7 +7177,7 @@
               </a:defRPr>
             </a:pPr>
             <a:r>
-              <a:t>•  Flask Web Application: Interactive clinician-facing dashboard for note entry / file upload.</a:t>
+              <a:t>•  Flask Web Application: Interactive clinician-facing dashboard for clinical note entry and automated triage.</a:t>
             </a:r>
           </a:p>
           <a:p>
@@ -7192,7 +7192,7 @@
               </a:defRPr>
             </a:pPr>
             <a:r>
-              <a:t>•  Live Prediction Pipeline: Transforms input text using serialized TF-IDF vectorizer.</a:t>
+              <a:t>•  Pipeline Serialization: Trained TF-IDF vectorizer and ensemble model are serialized together for deployment.</a:t>
             </a:r>
           </a:p>
           <a:p>
@@ -7207,7 +7207,7 @@
               </a:defRPr>
             </a:pPr>
             <a:r>
-              <a:t>•  Confidence Output: Returns predicted specialty and classification confidence percentage.</a:t>
+              <a:t>•  Confidence Output: Returns predicted specialty category and associated classification confidence percentage.</a:t>
             </a:r>
           </a:p>
         </p:txBody>
@@ -7726,7 +7726,7 @@
                   <a:srgbClr val="334155"/>
                 </a:solidFill>
               </a:rPr>
-              <a:t>Finalized 5-step sequence: Lowercasing, character cleaning, stop-word removal, and lemmatization.</a:t>
+              <a:t>Finalized 5-step sequence: Character Cleaning, Lowercasing, Tokenization, Stop-word Removal, and Lemmatization.</a:t>
             </a:r>
           </a:p>
           <a:p>
@@ -7772,7 +7772,7 @@
                   <a:srgbClr val="334155"/>
                 </a:solidFill>
               </a:rPr>
-              <a:t>Selected SVM (calibrated), RF, LR, MNB and soft voting probability consensus aggregation.</a:t>
+              <a:t>Selected Calibrated SVM, RF, LR, MNB and soft voting probability consensus aggregation.</a:t>
             </a:r>
           </a:p>
         </p:txBody>
@@ -7890,7 +7890,7 @@
               </a:defRPr>
             </a:pPr>
             <a:r>
-              <a:t>→  TF-IDF Matrix Generation &amp; Feature Export: </a:t>
+              <a:t>→  TF-IDF Vectorizer &amp; Feature Representation: </a:t>
             </a:r>
             <a:r>
               <a:rPr b="0" sz="850">
@@ -7898,7 +7898,7 @@
                   <a:srgbClr val="334155"/>
                 </a:solidFill>
               </a:rPr>
-              <a:t>Fit and persist TF-IDF vectorizer; compile high-dimensional sparse feature matrix.</a:t>
+              <a:t>Fit and persist TF-IDF vectorizer; generate high-dimensional sparse feature matrix.</a:t>
             </a:r>
           </a:p>
           <a:p>
@@ -7921,7 +7921,7 @@
                   <a:srgbClr val="334155"/>
                 </a:solidFill>
               </a:rPr>
-              <a:t>Train SVM, Random Forest, Logistic Regression, and Multinomial Naive Bayes candidate classifiers.</a:t>
+              <a:t>Train Calibrated SVM, Random Forest, Logistic Regression, and Multinomial Naive Bayes classifiers.</a:t>
             </a:r>
           </a:p>
           <a:p>
@@ -8443,7 +8443,7 @@
         <p:spPr>
           <a:xfrm>
             <a:off x="731520" y="1115568"/>
-            <a:ext cx="10728655" cy="475488"/>
+            <a:ext cx="10728655" cy="438912"/>
           </a:xfrm>
           <a:prstGeom prst="roundRect">
             <a:avLst/>
@@ -8487,8 +8487,8 @@
         </p:nvSpPr>
         <p:spPr>
           <a:xfrm>
-            <a:off x="868680" y="1170432"/>
-            <a:ext cx="10424160" cy="384048"/>
+            <a:off x="868680" y="1152144"/>
+            <a:ext cx="10424160" cy="365760"/>
           </a:xfrm>
           <a:prstGeom prst="rect">
             <a:avLst/>
@@ -8515,832 +8515,676 @@
           </a:p>
         </p:txBody>
       </p:sp>
-      <p:graphicFrame>
-        <p:nvGraphicFramePr>
-          <p:cNvPr id="12" name="Table 11"/>
-          <p:cNvGraphicFramePr>
-            <a:graphicFrameLocks noGrp="1"/>
-          </p:cNvGraphicFramePr>
-          <p:nvPr/>
-        </p:nvGraphicFramePr>
-        <p:xfrm>
-          <a:off x="731520" y="1691640"/>
-          <a:ext cx="10728655" cy="4526280"/>
-        </p:xfrm>
-        <a:graphic>
-          <a:graphicData uri="http://schemas.openxmlformats.org/drawingml/2006/table">
-            <a:tbl>
-              <a:tblPr firstRow="1" bandRow="1">
-                <a:tableStyleId>{5C22544A-7EE6-4342-B048-85BDC9FD1C3A}</a:tableStyleId>
-              </a:tblPr>
-              <a:tblGrid>
-                <a:gridCol w="2743200"/>
-                <a:gridCol w="7985455"/>
-              </a:tblGrid>
-              <a:tr h="282892">
-                <a:tc>
-                  <a:txBody>
-                    <a:bodyPr/>
-                    <a:lstStyle/>
-                    <a:p>
-                      <a:pPr>
-                        <a:defRPr sz="1000" b="1">
-                          <a:solidFill>
-                            <a:srgbClr val="FFFFFF"/>
-                          </a:solidFill>
-                          <a:latin typeface="Calibri"/>
-                        </a:defRPr>
-                      </a:pPr>
-                      <a:r>
-                        <a:t>Period / Date</a:t>
-                      </a:r>
-                    </a:p>
-                  </a:txBody>
-                  <a:tcPr marT="36576" marB="36576" marL="109728" marR="109728">
-                    <a:solidFill>
-                      <a:srgbClr val="0F172A"/>
-                    </a:solidFill>
-                  </a:tcPr>
-                </a:tc>
-                <a:tc>
-                  <a:txBody>
-                    <a:bodyPr/>
-                    <a:lstStyle/>
-                    <a:p>
-                      <a:pPr>
-                        <a:defRPr sz="1000" b="1">
-                          <a:solidFill>
-                            <a:srgbClr val="FFFFFF"/>
-                          </a:solidFill>
-                          <a:latin typeface="Calibri"/>
-                        </a:defRPr>
-                      </a:pPr>
-                      <a:r>
-                        <a:t>Planned Activity / Presentation Milestone</a:t>
-                      </a:r>
-                    </a:p>
-                  </a:txBody>
-                  <a:tcPr marT="36576" marB="36576" marL="109728" marR="109728">
-                    <a:solidFill>
-                      <a:srgbClr val="0F172A"/>
-                    </a:solidFill>
-                  </a:tcPr>
-                </a:tc>
-              </a:tr>
-              <a:tr h="282892">
-                <a:tc>
-                  <a:txBody>
-                    <a:bodyPr/>
-                    <a:lstStyle/>
-                    <a:p>
-                      <a:pPr>
-                        <a:defRPr sz="880" b="0">
-                          <a:solidFill>
-                            <a:srgbClr val="334155"/>
-                          </a:solidFill>
-                          <a:latin typeface="Calibri"/>
-                        </a:defRPr>
-                      </a:pPr>
-                      <a:r>
-                        <a:t>Week 1–2</a:t>
-                      </a:r>
-                    </a:p>
-                  </a:txBody>
-                  <a:tcPr marT="18288" marB="18288" marL="109728" marR="109728">
-                    <a:solidFill>
-                      <a:srgbClr val="FFFFFF"/>
-                    </a:solidFill>
-                  </a:tcPr>
-                </a:tc>
-                <a:tc>
-                  <a:txBody>
-                    <a:bodyPr/>
-                    <a:lstStyle/>
-                    <a:p>
-                      <a:pPr>
-                        <a:defRPr sz="880" b="0">
-                          <a:solidFill>
-                            <a:srgbClr val="334155"/>
-                          </a:solidFill>
-                          <a:latin typeface="Calibri"/>
-                        </a:defRPr>
-                      </a:pPr>
-                      <a:r>
-                        <a:t>Dataset Collection, Exploratory Data Analysis, and Initial Data Cleaning</a:t>
-                      </a:r>
-                    </a:p>
-                  </a:txBody>
-                  <a:tcPr marT="18288" marB="18288" marL="109728" marR="109728">
-                    <a:solidFill>
-                      <a:srgbClr val="FFFFFF"/>
-                    </a:solidFill>
-                  </a:tcPr>
-                </a:tc>
-              </a:tr>
-              <a:tr h="282892">
-                <a:tc>
-                  <a:txBody>
-                    <a:bodyPr/>
-                    <a:lstStyle/>
-                    <a:p>
-                      <a:pPr>
-                        <a:defRPr sz="880" b="1">
-                          <a:solidFill>
-                            <a:srgbClr val="0F172A"/>
-                          </a:solidFill>
-                          <a:latin typeface="Calibri"/>
-                        </a:defRPr>
-                      </a:pPr>
-                      <a:r>
-                        <a:t>21.07.2026</a:t>
-                      </a:r>
-                    </a:p>
-                  </a:txBody>
-                  <a:tcPr marT="18288" marB="18288" marL="109728" marR="109728">
-                    <a:solidFill>
-                      <a:srgbClr val="F8FAFC"/>
-                    </a:solidFill>
-                  </a:tcPr>
-                </a:tc>
-                <a:tc>
-                  <a:txBody>
-                    <a:bodyPr/>
-                    <a:lstStyle/>
-                    <a:p>
-                      <a:pPr>
-                        <a:defRPr sz="880" b="1">
-                          <a:solidFill>
-                            <a:srgbClr val="0F172A"/>
-                          </a:solidFill>
-                          <a:latin typeface="Calibri"/>
-                        </a:defRPr>
-                      </a:pPr>
-                      <a:r>
-                        <a:t>Project Proposal Approval</a:t>
-                      </a:r>
-                    </a:p>
-                  </a:txBody>
-                  <a:tcPr marT="18288" marB="18288" marL="109728" marR="109728">
-                    <a:solidFill>
-                      <a:srgbClr val="F8FAFC"/>
-                    </a:solidFill>
-                  </a:tcPr>
-                </a:tc>
-              </a:tr>
-              <a:tr h="282892">
-                <a:tc>
-                  <a:txBody>
-                    <a:bodyPr/>
-                    <a:lstStyle/>
-                    <a:p>
-                      <a:pPr>
-                        <a:defRPr sz="880" b="0">
-                          <a:solidFill>
-                            <a:srgbClr val="334155"/>
-                          </a:solidFill>
-                          <a:latin typeface="Calibri"/>
-                        </a:defRPr>
-                      </a:pPr>
-                      <a:r>
-                        <a:t>Week 3–4</a:t>
-                      </a:r>
-                    </a:p>
-                  </a:txBody>
-                  <a:tcPr marT="18288" marB="18288" marL="109728" marR="109728">
-                    <a:solidFill>
-                      <a:srgbClr val="FFFFFF"/>
-                    </a:solidFill>
-                  </a:tcPr>
-                </a:tc>
-                <a:tc>
-                  <a:txBody>
-                    <a:bodyPr/>
-                    <a:lstStyle/>
-                    <a:p>
-                      <a:pPr>
-                        <a:defRPr sz="880" b="0">
-                          <a:solidFill>
-                            <a:srgbClr val="334155"/>
-                          </a:solidFill>
-                          <a:latin typeface="Calibri"/>
-                        </a:defRPr>
-                      </a:pPr>
-                      <a:r>
-                        <a:t>Clinical Text Preprocessing, Medical Stop-word Removal, and Lemmatization</a:t>
-                      </a:r>
-                    </a:p>
-                  </a:txBody>
-                  <a:tcPr marT="18288" marB="18288" marL="109728" marR="109728">
-                    <a:solidFill>
-                      <a:srgbClr val="FFFFFF"/>
-                    </a:solidFill>
-                  </a:tcPr>
-                </a:tc>
-              </a:tr>
-              <a:tr h="282892">
-                <a:tc>
-                  <a:txBody>
-                    <a:bodyPr/>
-                    <a:lstStyle/>
-                    <a:p>
-                      <a:pPr>
-                        <a:defRPr sz="880" b="0">
-                          <a:solidFill>
-                            <a:srgbClr val="334155"/>
-                          </a:solidFill>
-                          <a:latin typeface="Calibri"/>
-                        </a:defRPr>
-                      </a:pPr>
-                      <a:r>
-                        <a:t>Week 5</a:t>
-                      </a:r>
-                    </a:p>
-                  </a:txBody>
-                  <a:tcPr marT="18288" marB="18288" marL="109728" marR="109728">
-                    <a:solidFill>
-                      <a:srgbClr val="F8FAFC"/>
-                    </a:solidFill>
-                  </a:tcPr>
-                </a:tc>
-                <a:tc>
-                  <a:txBody>
-                    <a:bodyPr/>
-                    <a:lstStyle/>
-                    <a:p>
-                      <a:pPr>
-                        <a:defRPr sz="880" b="0">
-                          <a:solidFill>
-                            <a:srgbClr val="334155"/>
-                          </a:solidFill>
-                          <a:latin typeface="Calibri"/>
-                        </a:defRPr>
-                      </a:pPr>
-                      <a:r>
-                        <a:t>TF-IDF Feature Extraction and Feature Representation Analysis</a:t>
-                      </a:r>
-                    </a:p>
-                  </a:txBody>
-                  <a:tcPr marT="18288" marB="18288" marL="109728" marR="109728">
-                    <a:solidFill>
-                      <a:srgbClr val="F8FAFC"/>
-                    </a:solidFill>
-                  </a:tcPr>
-                </a:tc>
-              </a:tr>
-              <a:tr h="282892">
-                <a:tc>
-                  <a:txBody>
-                    <a:bodyPr/>
-                    <a:lstStyle/>
-                    <a:p>
-                      <a:pPr>
-                        <a:defRPr sz="880" b="1">
-                          <a:solidFill>
-                            <a:srgbClr val="1D4ED8"/>
-                          </a:solidFill>
-                          <a:latin typeface="Calibri"/>
-                        </a:defRPr>
-                      </a:pPr>
-                      <a:r>
-                        <a:t>08.09.2026</a:t>
-                      </a:r>
-                    </a:p>
-                  </a:txBody>
-                  <a:tcPr marT="18288" marB="18288" marL="109728" marR="109728">
-                    <a:solidFill>
-                      <a:srgbClr val="EFF6FF"/>
-                    </a:solidFill>
-                  </a:tcPr>
-                </a:tc>
-                <a:tc>
-                  <a:txBody>
-                    <a:bodyPr/>
-                    <a:lstStyle/>
-                    <a:p>
-                      <a:pPr>
-                        <a:defRPr sz="880" b="1">
-                          <a:solidFill>
-                            <a:srgbClr val="1D4ED8"/>
-                          </a:solidFill>
-                          <a:latin typeface="Calibri"/>
-                        </a:defRPr>
-                      </a:pPr>
-                      <a:r>
-                        <a:t>First Project Presentation (Current Milestone — Phase 1 Faculty Review)</a:t>
-                      </a:r>
-                    </a:p>
-                  </a:txBody>
-                  <a:tcPr marT="18288" marB="18288" marL="109728" marR="109728">
-                    <a:solidFill>
-                      <a:srgbClr val="EFF6FF"/>
-                    </a:solidFill>
-                  </a:tcPr>
-                </a:tc>
-              </a:tr>
-              <a:tr h="282892">
-                <a:tc>
-                  <a:txBody>
-                    <a:bodyPr/>
-                    <a:lstStyle/>
-                    <a:p>
-                      <a:pPr>
-                        <a:defRPr sz="880" b="1">
-                          <a:solidFill>
-                            <a:srgbClr val="1D4ED8"/>
-                          </a:solidFill>
-                          <a:latin typeface="Calibri"/>
-                        </a:defRPr>
-                      </a:pPr>
-                      <a:r>
-                        <a:t>09.09.2026</a:t>
-                      </a:r>
-                    </a:p>
-                  </a:txBody>
-                  <a:tcPr marT="18288" marB="18288" marL="109728" marR="109728">
-                    <a:solidFill>
-                      <a:srgbClr val="EFF6FF"/>
-                    </a:solidFill>
-                  </a:tcPr>
-                </a:tc>
-                <a:tc>
-                  <a:txBody>
-                    <a:bodyPr/>
-                    <a:lstStyle/>
-                    <a:p>
-                      <a:pPr>
-                        <a:defRPr sz="880" b="1">
-                          <a:solidFill>
-                            <a:srgbClr val="1D4ED8"/>
-                          </a:solidFill>
-                          <a:latin typeface="Calibri"/>
-                        </a:defRPr>
-                      </a:pPr>
-                      <a:r>
-                        <a:t>Sprint Release I (Dataset Exploration &amp; Pipeline Architecture Completed)</a:t>
-                      </a:r>
-                    </a:p>
-                  </a:txBody>
-                  <a:tcPr marT="18288" marB="18288" marL="109728" marR="109728">
-                    <a:solidFill>
-                      <a:srgbClr val="EFF6FF"/>
-                    </a:solidFill>
-                  </a:tcPr>
-                </a:tc>
-              </a:tr>
-              <a:tr h="282892">
-                <a:tc>
-                  <a:txBody>
-                    <a:bodyPr/>
-                    <a:lstStyle/>
-                    <a:p>
-                      <a:pPr>
-                        <a:defRPr sz="880" b="0">
-                          <a:solidFill>
-                            <a:srgbClr val="334155"/>
-                          </a:solidFill>
-                          <a:latin typeface="Calibri"/>
-                        </a:defRPr>
-                      </a:pPr>
-                      <a:r>
-                        <a:t>Week 6</a:t>
-                      </a:r>
-                    </a:p>
-                  </a:txBody>
-                  <a:tcPr marT="18288" marB="18288" marL="109728" marR="109728">
-                    <a:solidFill>
-                      <a:srgbClr val="FFFFFF"/>
-                    </a:solidFill>
-                  </a:tcPr>
-                </a:tc>
-                <a:tc>
-                  <a:txBody>
-                    <a:bodyPr/>
-                    <a:lstStyle/>
-                    <a:p>
-                      <a:pPr>
-                        <a:defRPr sz="880" b="0">
-                          <a:solidFill>
-                            <a:srgbClr val="334155"/>
-                          </a:solidFill>
-                          <a:latin typeface="Calibri"/>
-                        </a:defRPr>
-                      </a:pPr>
-                      <a:r>
-                        <a:t>Candidate ML Model Training (SVM, Random Forest, Logistic Regression, MNB) and Baseline Evaluation</a:t>
-                      </a:r>
-                    </a:p>
-                  </a:txBody>
-                  <a:tcPr marT="18288" marB="18288" marL="109728" marR="109728">
-                    <a:solidFill>
-                      <a:srgbClr val="FFFFFF"/>
-                    </a:solidFill>
-                  </a:tcPr>
-                </a:tc>
-              </a:tr>
-              <a:tr h="282892">
-                <a:tc>
-                  <a:txBody>
-                    <a:bodyPr/>
-                    <a:lstStyle/>
-                    <a:p>
-                      <a:pPr>
-                        <a:defRPr sz="880" b="1">
-                          <a:solidFill>
-                            <a:srgbClr val="0F172A"/>
-                          </a:solidFill>
-                          <a:latin typeface="Calibri"/>
-                        </a:defRPr>
-                      </a:pPr>
-                      <a:r>
-                        <a:t>18.09.2026</a:t>
-                      </a:r>
-                    </a:p>
-                  </a:txBody>
-                  <a:tcPr marT="18288" marB="18288" marL="109728" marR="109728">
-                    <a:solidFill>
-                      <a:srgbClr val="F8FAFC"/>
-                    </a:solidFill>
-                  </a:tcPr>
-                </a:tc>
-                <a:tc>
-                  <a:txBody>
-                    <a:bodyPr/>
-                    <a:lstStyle/>
-                    <a:p>
-                      <a:pPr>
-                        <a:defRPr sz="880" b="1">
-                          <a:solidFill>
-                            <a:srgbClr val="0F172A"/>
-                          </a:solidFill>
-                          <a:latin typeface="Calibri"/>
-                        </a:defRPr>
-                      </a:pPr>
-                      <a:r>
-                        <a:t>Sprint Release II</a:t>
-                      </a:r>
-                    </a:p>
-                  </a:txBody>
-                  <a:tcPr marT="18288" marB="18288" marL="109728" marR="109728">
-                    <a:solidFill>
-                      <a:srgbClr val="F8FAFC"/>
-                    </a:solidFill>
-                  </a:tcPr>
-                </a:tc>
-              </a:tr>
-              <a:tr h="282892">
-                <a:tc>
-                  <a:txBody>
-                    <a:bodyPr/>
-                    <a:lstStyle/>
-                    <a:p>
-                      <a:pPr>
-                        <a:defRPr sz="880" b="0">
-                          <a:solidFill>
-                            <a:srgbClr val="334155"/>
-                          </a:solidFill>
-                          <a:latin typeface="Calibri"/>
-                        </a:defRPr>
-                      </a:pPr>
-                      <a:r>
-                        <a:t>Week 7–8</a:t>
-                      </a:r>
-                    </a:p>
-                  </a:txBody>
-                  <a:tcPr marT="18288" marB="18288" marL="109728" marR="109728">
-                    <a:solidFill>
-                      <a:srgbClr val="FFFFFF"/>
-                    </a:solidFill>
-                  </a:tcPr>
-                </a:tc>
-                <a:tc>
-                  <a:txBody>
-                    <a:bodyPr/>
-                    <a:lstStyle/>
-                    <a:p>
-                      <a:pPr>
-                        <a:defRPr sz="880" b="0">
-                          <a:solidFill>
-                            <a:srgbClr val="334155"/>
-                          </a:solidFill>
-                          <a:latin typeface="Calibri"/>
-                        </a:defRPr>
-                      </a:pPr>
-                      <a:r>
-                        <a:t>Soft Voting Ensemble Formulation, Grid Search Hyperparameter Tuning, and Web UI Design</a:t>
-                      </a:r>
-                    </a:p>
-                  </a:txBody>
-                  <a:tcPr marT="18288" marB="18288" marL="109728" marR="109728">
-                    <a:solidFill>
-                      <a:srgbClr val="FFFFFF"/>
-                    </a:solidFill>
-                  </a:tcPr>
-                </a:tc>
-              </a:tr>
-              <a:tr h="282892">
-                <a:tc>
-                  <a:txBody>
-                    <a:bodyPr/>
-                    <a:lstStyle/>
-                    <a:p>
-                      <a:pPr>
-                        <a:defRPr sz="880" b="1">
-                          <a:solidFill>
-                            <a:srgbClr val="0F172A"/>
-                          </a:solidFill>
-                          <a:latin typeface="Calibri"/>
-                        </a:defRPr>
-                      </a:pPr>
-                      <a:r>
-                        <a:t>29.09.2026 – 30.09.2026</a:t>
-                      </a:r>
-                    </a:p>
-                  </a:txBody>
-                  <a:tcPr marT="18288" marB="18288" marL="109728" marR="109728">
-                    <a:solidFill>
-                      <a:srgbClr val="F8FAFC"/>
-                    </a:solidFill>
-                  </a:tcPr>
-                </a:tc>
-                <a:tc>
-                  <a:txBody>
-                    <a:bodyPr/>
-                    <a:lstStyle/>
-                    <a:p>
-                      <a:pPr>
-                        <a:defRPr sz="880" b="1">
-                          <a:solidFill>
-                            <a:srgbClr val="0F172A"/>
-                          </a:solidFill>
-                          <a:latin typeface="Calibri"/>
-                        </a:defRPr>
-                      </a:pPr>
-                      <a:r>
-                        <a:t>Interim Project Presentation</a:t>
-                      </a:r>
-                    </a:p>
-                  </a:txBody>
-                  <a:tcPr marT="18288" marB="18288" marL="109728" marR="109728">
-                    <a:solidFill>
-                      <a:srgbClr val="F8FAFC"/>
-                    </a:solidFill>
-                  </a:tcPr>
-                </a:tc>
-              </a:tr>
-              <a:tr h="282892">
-                <a:tc>
-                  <a:txBody>
-                    <a:bodyPr/>
-                    <a:lstStyle/>
-                    <a:p>
-                      <a:pPr>
-                        <a:defRPr sz="880" b="0">
-                          <a:solidFill>
-                            <a:srgbClr val="334155"/>
-                          </a:solidFill>
-                          <a:latin typeface="Calibri"/>
-                        </a:defRPr>
-                      </a:pPr>
-                      <a:r>
-                        <a:t>Week 9</a:t>
-                      </a:r>
-                    </a:p>
-                  </a:txBody>
-                  <a:tcPr marT="18288" marB="18288" marL="109728" marR="109728">
-                    <a:solidFill>
-                      <a:srgbClr val="FFFFFF"/>
-                    </a:solidFill>
-                  </a:tcPr>
-                </a:tc>
-                <a:tc>
-                  <a:txBody>
-                    <a:bodyPr/>
-                    <a:lstStyle/>
-                    <a:p>
-                      <a:pPr>
-                        <a:defRPr sz="880" b="0">
-                          <a:solidFill>
-                            <a:srgbClr val="334155"/>
-                          </a:solidFill>
-                          <a:latin typeface="Calibri"/>
-                        </a:defRPr>
-                      </a:pPr>
-                      <a:r>
-                        <a:t>Flask Web Application Integration, Route Setup, and Serialized Pipeline Deployment</a:t>
-                      </a:r>
-                    </a:p>
-                  </a:txBody>
-                  <a:tcPr marT="18288" marB="18288" marL="109728" marR="109728">
-                    <a:solidFill>
-                      <a:srgbClr val="FFFFFF"/>
-                    </a:solidFill>
-                  </a:tcPr>
-                </a:tc>
-              </a:tr>
-              <a:tr h="282892">
-                <a:tc>
-                  <a:txBody>
-                    <a:bodyPr/>
-                    <a:lstStyle/>
-                    <a:p>
-                      <a:pPr>
-                        <a:defRPr sz="880" b="1">
-                          <a:solidFill>
-                            <a:srgbClr val="0F172A"/>
-                          </a:solidFill>
-                          <a:latin typeface="Calibri"/>
-                        </a:defRPr>
-                      </a:pPr>
-                      <a:r>
-                        <a:t>09.10.2026</a:t>
-                      </a:r>
-                    </a:p>
-                  </a:txBody>
-                  <a:tcPr marT="18288" marB="18288" marL="109728" marR="109728">
-                    <a:solidFill>
-                      <a:srgbClr val="F8FAFC"/>
-                    </a:solidFill>
-                  </a:tcPr>
-                </a:tc>
-                <a:tc>
-                  <a:txBody>
-                    <a:bodyPr/>
-                    <a:lstStyle/>
-                    <a:p>
-                      <a:pPr>
-                        <a:defRPr sz="880" b="1">
-                          <a:solidFill>
-                            <a:srgbClr val="0F172A"/>
-                          </a:solidFill>
-                          <a:latin typeface="Calibri"/>
-                        </a:defRPr>
-                      </a:pPr>
-                      <a:r>
-                        <a:t>Sprint Release III</a:t>
-                      </a:r>
-                    </a:p>
-                  </a:txBody>
-                  <a:tcPr marT="18288" marB="18288" marL="109728" marR="109728">
-                    <a:solidFill>
-                      <a:srgbClr val="F8FAFC"/>
-                    </a:solidFill>
-                  </a:tcPr>
-                </a:tc>
-              </a:tr>
-              <a:tr h="282892">
-                <a:tc>
-                  <a:txBody>
-                    <a:bodyPr/>
-                    <a:lstStyle/>
-                    <a:p>
-                      <a:pPr>
-                        <a:defRPr sz="880" b="0">
-                          <a:solidFill>
-                            <a:srgbClr val="334155"/>
-                          </a:solidFill>
-                          <a:latin typeface="Calibri"/>
-                        </a:defRPr>
-                      </a:pPr>
-                      <a:r>
-                        <a:t>Week 10–11</a:t>
-                      </a:r>
-                    </a:p>
-                  </a:txBody>
-                  <a:tcPr marT="18288" marB="18288" marL="109728" marR="109728">
-                    <a:solidFill>
-                      <a:srgbClr val="FFFFFF"/>
-                    </a:solidFill>
-                  </a:tcPr>
-                </a:tc>
-                <a:tc>
-                  <a:txBody>
-                    <a:bodyPr/>
-                    <a:lstStyle/>
-                    <a:p>
-                      <a:pPr>
-                        <a:defRPr sz="880" b="0">
-                          <a:solidFill>
-                            <a:srgbClr val="334155"/>
-                          </a:solidFill>
-                          <a:latin typeface="Calibri"/>
-                        </a:defRPr>
-                      </a:pPr>
-                      <a:r>
-                        <a:t>Multi-Class Evaluation, Confusion Matrix Analysis, Threshold Tuning, and System Testing</a:t>
-                      </a:r>
-                    </a:p>
-                  </a:txBody>
-                  <a:tcPr marT="18288" marB="18288" marL="109728" marR="109728">
-                    <a:solidFill>
-                      <a:srgbClr val="FFFFFF"/>
-                    </a:solidFill>
-                  </a:tcPr>
-                </a:tc>
-              </a:tr>
-              <a:tr h="282892">
-                <a:tc>
-                  <a:txBody>
-                    <a:bodyPr/>
-                    <a:lstStyle/>
-                    <a:p>
-                      <a:pPr>
-                        <a:defRPr sz="880" b="1">
-                          <a:solidFill>
-                            <a:srgbClr val="0F172A"/>
-                          </a:solidFill>
-                          <a:latin typeface="Calibri"/>
-                        </a:defRPr>
-                      </a:pPr>
-                      <a:r>
-                        <a:t>22.10.2026 – 23.10.2026</a:t>
-                      </a:r>
-                    </a:p>
-                  </a:txBody>
-                  <a:tcPr marT="18288" marB="18288" marL="109728" marR="109728">
-                    <a:solidFill>
-                      <a:srgbClr val="F8FAFC"/>
-                    </a:solidFill>
-                  </a:tcPr>
-                </a:tc>
-                <a:tc>
-                  <a:txBody>
-                    <a:bodyPr/>
-                    <a:lstStyle/>
-                    <a:p>
-                      <a:pPr>
-                        <a:defRPr sz="880" b="1">
-                          <a:solidFill>
-                            <a:srgbClr val="0F172A"/>
-                          </a:solidFill>
-                          <a:latin typeface="Calibri"/>
-                        </a:defRPr>
-                      </a:pPr>
-                      <a:r>
-                        <a:t>Final Project Presentation</a:t>
-                      </a:r>
-                    </a:p>
-                  </a:txBody>
-                  <a:tcPr marT="18288" marB="18288" marL="109728" marR="109728">
-                    <a:solidFill>
-                      <a:srgbClr val="F8FAFC"/>
-                    </a:solidFill>
-                  </a:tcPr>
-                </a:tc>
-              </a:tr>
-              <a:tr h="282900">
-                <a:tc>
-                  <a:txBody>
-                    <a:bodyPr/>
-                    <a:lstStyle/>
-                    <a:p>
-                      <a:pPr>
-                        <a:defRPr sz="880" b="1">
-                          <a:solidFill>
-                            <a:srgbClr val="0F172A"/>
-                          </a:solidFill>
-                          <a:latin typeface="Calibri"/>
-                        </a:defRPr>
-                      </a:pPr>
-                      <a:r>
-                        <a:t>30.10.2026</a:t>
-                      </a:r>
-                    </a:p>
-                  </a:txBody>
-                  <a:tcPr marT="18288" marB="18288" marL="109728" marR="109728">
-                    <a:solidFill>
-                      <a:srgbClr val="FFFFFF"/>
-                    </a:solidFill>
-                  </a:tcPr>
-                </a:tc>
-                <a:tc>
-                  <a:txBody>
-                    <a:bodyPr/>
-                    <a:lstStyle/>
-                    <a:p>
-                      <a:pPr>
-                        <a:defRPr sz="880" b="1">
-                          <a:solidFill>
-                            <a:srgbClr val="0F172A"/>
-                          </a:solidFill>
-                          <a:latin typeface="Calibri"/>
-                        </a:defRPr>
-                      </a:pPr>
-                      <a:r>
-                        <a:t>Final Report Submission</a:t>
-                      </a:r>
-                    </a:p>
-                  </a:txBody>
-                  <a:tcPr marT="18288" marB="18288" marL="109728" marR="109728">
-                    <a:solidFill>
-                      <a:srgbClr val="FFFFFF"/>
-                    </a:solidFill>
-                  </a:tcPr>
-                </a:tc>
-              </a:tr>
-            </a:tbl>
-          </a:graphicData>
-        </a:graphic>
-      </p:graphicFrame>
+      <p:sp>
+        <p:nvSpPr>
+          <p:cNvPr id="12" name="Rounded Rectangle 11"/>
+          <p:cNvSpPr/>
+          <p:nvPr/>
+        </p:nvSpPr>
+        <p:spPr>
+          <a:xfrm>
+            <a:off x="731520" y="1645920"/>
+            <a:ext cx="5230368" cy="4617720"/>
+          </a:xfrm>
+          <a:prstGeom prst="roundRect">
+            <a:avLst/>
+          </a:prstGeom>
+          <a:solidFill>
+            <a:srgbClr val="FFFFFF"/>
+          </a:solidFill>
+          <a:ln w="12700">
+            <a:solidFill>
+              <a:srgbClr val="BBF7D0"/>
+            </a:solidFill>
+          </a:ln>
+        </p:spPr>
+        <p:style>
+          <a:lnRef idx="1">
+            <a:schemeClr val="accent1"/>
+          </a:lnRef>
+          <a:fillRef idx="3">
+            <a:schemeClr val="accent1"/>
+          </a:fillRef>
+          <a:effectRef idx="2">
+            <a:schemeClr val="accent1"/>
+          </a:effectRef>
+          <a:fontRef idx="minor">
+            <a:schemeClr val="lt1"/>
+          </a:fontRef>
+        </p:style>
+        <p:txBody>
+          <a:bodyPr rtlCol="0" anchor="ctr"/>
+          <a:lstStyle/>
+          <a:p>
+            <a:pPr algn="ctr"/>
+          </a:p>
+        </p:txBody>
+      </p:sp>
+      <p:sp>
+        <p:nvSpPr>
+          <p:cNvPr id="13" name="TextBox 12"/>
+          <p:cNvSpPr txBox="1"/>
+          <p:nvPr/>
+        </p:nvSpPr>
+        <p:spPr>
+          <a:xfrm>
+            <a:off x="896112" y="1755648"/>
+            <a:ext cx="4901184" cy="4398264"/>
+          </a:xfrm>
+          <a:prstGeom prst="rect">
+            <a:avLst/>
+          </a:prstGeom>
+          <a:noFill/>
+        </p:spPr>
+        <p:txBody>
+          <a:bodyPr wrap="square">
+            <a:spAutoFit/>
+          </a:bodyPr>
+          <a:lstStyle/>
+          <a:p>
+            <a:pPr>
+              <a:defRPr sz="1100" b="1">
+                <a:solidFill>
+                  <a:srgbClr val="166534"/>
+                </a:solidFill>
+              </a:defRPr>
+            </a:pPr>
+            <a:r>
+              <a:t>PHASE 1: FOUNDATION &amp; SPRINT RELEASE I</a:t>
+            </a:r>
+          </a:p>
+          <a:p>
+            <a:pPr>
+              <a:spcBef>
+                <a:spcPts val="500"/>
+              </a:spcBef>
+              <a:defRPr sz="919" b="1">
+                <a:solidFill>
+                  <a:srgbClr val="0F172A"/>
+                </a:solidFill>
+              </a:defRPr>
+            </a:pPr>
+            <a:r>
+              <a:t>✓  [17.07.2026]  Project Proposal &amp; Synopsis Approval by Guide</a:t>
+            </a:r>
+          </a:p>
+          <a:p>
+            <a:pPr>
+              <a:spcBef>
+                <a:spcPts val="100"/>
+              </a:spcBef>
+              <a:defRPr sz="819">
+                <a:solidFill>
+                  <a:srgbClr val="334155"/>
+                </a:solidFill>
+              </a:defRPr>
+            </a:pPr>
+            <a:r>
+              <a:t>     Formal approval of project scope, objectives, and feasibility by faculty guide.</a:t>
+            </a:r>
+          </a:p>
+          <a:p>
+            <a:pPr>
+              <a:spcBef>
+                <a:spcPts val="500"/>
+              </a:spcBef>
+              <a:defRPr sz="919" b="1">
+                <a:solidFill>
+                  <a:srgbClr val="0F172A"/>
+                </a:solidFill>
+              </a:defRPr>
+            </a:pPr>
+            <a:r>
+              <a:t>✓  [20.07.2026 – 21.07.2026]  Project Proposal Presentation</a:t>
+            </a:r>
+          </a:p>
+          <a:p>
+            <a:pPr>
+              <a:spcBef>
+                <a:spcPts val="100"/>
+              </a:spcBef>
+              <a:defRPr sz="819">
+                <a:solidFill>
+                  <a:srgbClr val="334155"/>
+                </a:solidFill>
+              </a:defRPr>
+            </a:pPr>
+            <a:r>
+              <a:t>     Presented proposal before Department Project Approval Committee.</a:t>
+            </a:r>
+          </a:p>
+          <a:p>
+            <a:pPr>
+              <a:spcBef>
+                <a:spcPts val="500"/>
+              </a:spcBef>
+              <a:defRPr sz="919" b="1">
+                <a:solidFill>
+                  <a:srgbClr val="0F172A"/>
+                </a:solidFill>
+              </a:defRPr>
+            </a:pPr>
+            <a:r>
+              <a:t>✓  [Weeks 1–2]  Dataset Collection &amp; Exploratory Data Analysis</a:t>
+            </a:r>
+          </a:p>
+          <a:p>
+            <a:pPr>
+              <a:spcBef>
+                <a:spcPts val="100"/>
+              </a:spcBef>
+              <a:defRPr sz="819">
+                <a:solidFill>
+                  <a:srgbClr val="334155"/>
+                </a:solidFill>
+              </a:defRPr>
+            </a:pPr>
+            <a:r>
+              <a:t>     Acquired Kaggle MTSamples (4,999 records); audited nulls and generated 6 EDA plots.</a:t>
+            </a:r>
+          </a:p>
+          <a:p>
+            <a:pPr>
+              <a:spcBef>
+                <a:spcPts val="500"/>
+              </a:spcBef>
+              <a:defRPr sz="919" b="1">
+                <a:solidFill>
+                  <a:srgbClr val="0F172A"/>
+                </a:solidFill>
+              </a:defRPr>
+            </a:pPr>
+            <a:r>
+              <a:t>✓  [Weeks 3–4]  Clinical Text Preprocessing Pipeline</a:t>
+            </a:r>
+          </a:p>
+          <a:p>
+            <a:pPr>
+              <a:spcBef>
+                <a:spcPts val="100"/>
+              </a:spcBef>
+              <a:defRPr sz="819">
+                <a:solidFill>
+                  <a:srgbClr val="334155"/>
+                </a:solidFill>
+              </a:defRPr>
+            </a:pPr>
+            <a:r>
+              <a:t>     Designed 5-step sequence: Cleaning, Lowercasing, Tokenization, Stop-words, Lemmatization.</a:t>
+            </a:r>
+          </a:p>
+          <a:p>
+            <a:pPr>
+              <a:spcBef>
+                <a:spcPts val="500"/>
+              </a:spcBef>
+              <a:defRPr sz="919" b="1">
+                <a:solidFill>
+                  <a:srgbClr val="0F172A"/>
+                </a:solidFill>
+              </a:defRPr>
+            </a:pPr>
+            <a:r>
+              <a:t>✓  [Week 5]  TF-IDF Vectorization Architecture</a:t>
+            </a:r>
+          </a:p>
+          <a:p>
+            <a:pPr>
+              <a:spcBef>
+                <a:spcPts val="100"/>
+              </a:spcBef>
+              <a:defRPr sz="819">
+                <a:solidFill>
+                  <a:srgbClr val="334155"/>
+                </a:solidFill>
+              </a:defRPr>
+            </a:pPr>
+            <a:r>
+              <a:t>     Formulated unigram/bigram tokenization with sublinear scaling and sparse matrix layout.</a:t>
+            </a:r>
+          </a:p>
+          <a:p>
+            <a:pPr>
+              <a:spcBef>
+                <a:spcPts val="500"/>
+              </a:spcBef>
+              <a:defRPr sz="919" b="1">
+                <a:solidFill>
+                  <a:srgbClr val="1D4ED8"/>
+                </a:solidFill>
+              </a:defRPr>
+            </a:pPr>
+            <a:r>
+              <a:t>★  [08.09.2026]  First Project Presentation ★</a:t>
+            </a:r>
+          </a:p>
+          <a:p>
+            <a:pPr>
+              <a:spcBef>
+                <a:spcPts val="100"/>
+              </a:spcBef>
+              <a:defRPr sz="819">
+                <a:solidFill>
+                  <a:srgbClr val="334155"/>
+                </a:solidFill>
+              </a:defRPr>
+            </a:pPr>
+            <a:r>
+              <a:t>     Current Milestone — Phase 1 Faculty Review &amp; Initial Progress Defense.</a:t>
+            </a:r>
+          </a:p>
+          <a:p>
+            <a:pPr>
+              <a:spcBef>
+                <a:spcPts val="500"/>
+              </a:spcBef>
+              <a:defRPr sz="919" b="1">
+                <a:solidFill>
+                  <a:srgbClr val="1D4ED8"/>
+                </a:solidFill>
+              </a:defRPr>
+            </a:pPr>
+            <a:r>
+              <a:t>★  [09.09.2026]  Sprint Release I ★</a:t>
+            </a:r>
+          </a:p>
+          <a:p>
+            <a:pPr>
+              <a:spcBef>
+                <a:spcPts val="100"/>
+              </a:spcBef>
+              <a:defRPr sz="819">
+                <a:solidFill>
+                  <a:srgbClr val="334155"/>
+                </a:solidFill>
+              </a:defRPr>
+            </a:pPr>
+            <a:r>
+              <a:t>     Formal submission: EDA diagrams, architecture specifications, and Phase 1 report.</a:t>
+            </a:r>
+          </a:p>
+        </p:txBody>
+      </p:sp>
+      <p:sp>
+        <p:nvSpPr>
+          <p:cNvPr id="14" name="Rounded Rectangle 13"/>
+          <p:cNvSpPr/>
+          <p:nvPr/>
+        </p:nvSpPr>
+        <p:spPr>
+          <a:xfrm>
+            <a:off x="6217920" y="1645920"/>
+            <a:ext cx="5230368" cy="4617720"/>
+          </a:xfrm>
+          <a:prstGeom prst="roundRect">
+            <a:avLst/>
+          </a:prstGeom>
+          <a:solidFill>
+            <a:srgbClr val="FFFFFF"/>
+          </a:solidFill>
+          <a:ln w="12700">
+            <a:solidFill>
+              <a:srgbClr val="BFDBFE"/>
+            </a:solidFill>
+          </a:ln>
+        </p:spPr>
+        <p:style>
+          <a:lnRef idx="1">
+            <a:schemeClr val="accent1"/>
+          </a:lnRef>
+          <a:fillRef idx="3">
+            <a:schemeClr val="accent1"/>
+          </a:fillRef>
+          <a:effectRef idx="2">
+            <a:schemeClr val="accent1"/>
+          </a:effectRef>
+          <a:fontRef idx="minor">
+            <a:schemeClr val="lt1"/>
+          </a:fontRef>
+        </p:style>
+        <p:txBody>
+          <a:bodyPr rtlCol="0" anchor="ctr"/>
+          <a:lstStyle/>
+          <a:p>
+            <a:pPr algn="ctr"/>
+          </a:p>
+        </p:txBody>
+      </p:sp>
+      <p:sp>
+        <p:nvSpPr>
+          <p:cNvPr id="15" name="TextBox 14"/>
+          <p:cNvSpPr txBox="1"/>
+          <p:nvPr/>
+        </p:nvSpPr>
+        <p:spPr>
+          <a:xfrm>
+            <a:off x="6382512" y="1755648"/>
+            <a:ext cx="4901184" cy="4398264"/>
+          </a:xfrm>
+          <a:prstGeom prst="rect">
+            <a:avLst/>
+          </a:prstGeom>
+          <a:noFill/>
+        </p:spPr>
+        <p:txBody>
+          <a:bodyPr wrap="square">
+            <a:spAutoFit/>
+          </a:bodyPr>
+          <a:lstStyle/>
+          <a:p>
+            <a:pPr>
+              <a:defRPr sz="1100" b="1">
+                <a:solidFill>
+                  <a:srgbClr val="1D4ED8"/>
+                </a:solidFill>
+              </a:defRPr>
+            </a:pPr>
+            <a:r>
+              <a:t>PHASES 2 &amp; 3: MODEL BUILDING, ENSEMBLE &amp; DEPLOYMENT</a:t>
+            </a:r>
+          </a:p>
+          <a:p>
+            <a:pPr>
+              <a:spcBef>
+                <a:spcPts val="300"/>
+              </a:spcBef>
+              <a:defRPr sz="880" b="1">
+                <a:solidFill>
+                  <a:srgbClr val="0F172A"/>
+                </a:solidFill>
+              </a:defRPr>
+            </a:pPr>
+            <a:r>
+              <a:t>→  [Week 6]  Candidate Model Training &amp; Baseline Evaluation</a:t>
+            </a:r>
+          </a:p>
+          <a:p>
+            <a:pPr>
+              <a:spcBef>
+                <a:spcPts val="100"/>
+              </a:spcBef>
+              <a:defRPr sz="800">
+                <a:solidFill>
+                  <a:srgbClr val="334155"/>
+                </a:solidFill>
+              </a:defRPr>
+            </a:pPr>
+            <a:r>
+              <a:t>     Train Calibrated SVM, Random Forest, Logistic Regression, and MNB.</a:t>
+            </a:r>
+          </a:p>
+          <a:p>
+            <a:pPr>
+              <a:spcBef>
+                <a:spcPts val="300"/>
+              </a:spcBef>
+              <a:defRPr sz="880" b="1">
+                <a:solidFill>
+                  <a:srgbClr val="7C3AED"/>
+                </a:solidFill>
+              </a:defRPr>
+            </a:pPr>
+            <a:r>
+              <a:t>★  [18.09.2026]  Sprint Release II ★</a:t>
+            </a:r>
+          </a:p>
+          <a:p>
+            <a:pPr>
+              <a:spcBef>
+                <a:spcPts val="100"/>
+              </a:spcBef>
+              <a:defRPr sz="800">
+                <a:solidFill>
+                  <a:srgbClr val="334155"/>
+                </a:solidFill>
+              </a:defRPr>
+            </a:pPr>
+            <a:r>
+              <a:t>     Milestone release: Trained baseline classifiers and preliminary metrics.</a:t>
+            </a:r>
+          </a:p>
+          <a:p>
+            <a:pPr>
+              <a:spcBef>
+                <a:spcPts val="300"/>
+              </a:spcBef>
+              <a:defRPr sz="880" b="1">
+                <a:solidFill>
+                  <a:srgbClr val="0F172A"/>
+                </a:solidFill>
+              </a:defRPr>
+            </a:pPr>
+            <a:r>
+              <a:t>→  [Week 7]  Hyperparameter Tuning &amp; Model Comparison</a:t>
+            </a:r>
+          </a:p>
+          <a:p>
+            <a:pPr>
+              <a:spcBef>
+                <a:spcPts val="100"/>
+              </a:spcBef>
+              <a:defRPr sz="800">
+                <a:solidFill>
+                  <a:srgbClr val="334155"/>
+                </a:solidFill>
+              </a:defRPr>
+            </a:pPr>
+            <a:r>
+              <a:t>     Systematic tuning and comparative performance profiling across candidate estimators.</a:t>
+            </a:r>
+          </a:p>
+          <a:p>
+            <a:pPr>
+              <a:spcBef>
+                <a:spcPts val="300"/>
+              </a:spcBef>
+              <a:defRPr sz="880" b="1">
+                <a:solidFill>
+                  <a:srgbClr val="0F172A"/>
+                </a:solidFill>
+              </a:defRPr>
+            </a:pPr>
+            <a:r>
+              <a:t>→  [Week 8]  Soft Voting Ensemble Implementation</a:t>
+            </a:r>
+          </a:p>
+          <a:p>
+            <a:pPr>
+              <a:spcBef>
+                <a:spcPts val="100"/>
+              </a:spcBef>
+              <a:defRPr sz="800">
+                <a:solidFill>
+                  <a:srgbClr val="334155"/>
+                </a:solidFill>
+              </a:defRPr>
+            </a:pPr>
+            <a:r>
+              <a:t>     Construct soft voting ensemble; aggregate consensus probability distributions.</a:t>
+            </a:r>
+          </a:p>
+          <a:p>
+            <a:pPr>
+              <a:spcBef>
+                <a:spcPts val="300"/>
+              </a:spcBef>
+              <a:defRPr sz="880" b="1">
+                <a:solidFill>
+                  <a:srgbClr val="7C3AED"/>
+                </a:solidFill>
+              </a:defRPr>
+            </a:pPr>
+            <a:r>
+              <a:t>★  [29.09.2026 – 30.09.2026]  Interim Project Presentation ★</a:t>
+            </a:r>
+          </a:p>
+          <a:p>
+            <a:pPr>
+              <a:spcBef>
+                <a:spcPts val="100"/>
+              </a:spcBef>
+              <a:defRPr sz="800">
+                <a:solidFill>
+                  <a:srgbClr val="334155"/>
+                </a:solidFill>
+              </a:defRPr>
+            </a:pPr>
+            <a:r>
+              <a:t>     Progress review and working model demonstration before faculty committee.</a:t>
+            </a:r>
+          </a:p>
+          <a:p>
+            <a:pPr>
+              <a:spcBef>
+                <a:spcPts val="300"/>
+              </a:spcBef>
+              <a:defRPr sz="880" b="1">
+                <a:solidFill>
+                  <a:srgbClr val="0F172A"/>
+                </a:solidFill>
+              </a:defRPr>
+            </a:pPr>
+            <a:r>
+              <a:t>→  [Week 9]  Flask Web Integration &amp; Serialization</a:t>
+            </a:r>
+          </a:p>
+          <a:p>
+            <a:pPr>
+              <a:spcBef>
+                <a:spcPts val="100"/>
+              </a:spcBef>
+              <a:defRPr sz="800">
+                <a:solidFill>
+                  <a:srgbClr val="334155"/>
+                </a:solidFill>
+              </a:defRPr>
+            </a:pPr>
+            <a:r>
+              <a:t>     Serialize pipeline with Joblib; build interactive clinician UI for live inference.</a:t>
+            </a:r>
+          </a:p>
+          <a:p>
+            <a:pPr>
+              <a:spcBef>
+                <a:spcPts val="300"/>
+              </a:spcBef>
+              <a:defRPr sz="880" b="1">
+                <a:solidFill>
+                  <a:srgbClr val="7C3AED"/>
+                </a:solidFill>
+              </a:defRPr>
+            </a:pPr>
+            <a:r>
+              <a:t>★  [09.10.2026]  Sprint Release III ★</a:t>
+            </a:r>
+          </a:p>
+          <a:p>
+            <a:pPr>
+              <a:spcBef>
+                <a:spcPts val="100"/>
+              </a:spcBef>
+              <a:defRPr sz="800">
+                <a:solidFill>
+                  <a:srgbClr val="334155"/>
+                </a:solidFill>
+              </a:defRPr>
+            </a:pPr>
+            <a:r>
+              <a:t>     Integrated system release: Flask web application and serialized ensemble.</a:t>
+            </a:r>
+          </a:p>
+          <a:p>
+            <a:pPr>
+              <a:spcBef>
+                <a:spcPts val="300"/>
+              </a:spcBef>
+              <a:defRPr sz="880" b="1">
+                <a:solidFill>
+                  <a:srgbClr val="0F172A"/>
+                </a:solidFill>
+              </a:defRPr>
+            </a:pPr>
+            <a:r>
+              <a:t>→  [Weeks 10–11]  Evaluation &amp; System Testing</a:t>
+            </a:r>
+          </a:p>
+          <a:p>
+            <a:pPr>
+              <a:spcBef>
+                <a:spcPts val="100"/>
+              </a:spcBef>
+              <a:defRPr sz="800">
+                <a:solidFill>
+                  <a:srgbClr val="334155"/>
+                </a:solidFill>
+              </a:defRPr>
+            </a:pPr>
+            <a:r>
+              <a:t>     Multi-class metrics (Macro F1, Recall), confusion matrix analysis, and validation.</a:t>
+            </a:r>
+          </a:p>
+          <a:p>
+            <a:pPr>
+              <a:spcBef>
+                <a:spcPts val="300"/>
+              </a:spcBef>
+              <a:defRPr sz="880" b="1">
+                <a:solidFill>
+                  <a:srgbClr val="7C3AED"/>
+                </a:solidFill>
+              </a:defRPr>
+            </a:pPr>
+            <a:r>
+              <a:t>★  [22.10.2026 – 23.10.2026]  Final Project Presentation ★</a:t>
+            </a:r>
+          </a:p>
+          <a:p>
+            <a:pPr>
+              <a:spcBef>
+                <a:spcPts val="100"/>
+              </a:spcBef>
+              <a:defRPr sz="800">
+                <a:solidFill>
+                  <a:srgbClr val="334155"/>
+                </a:solidFill>
+              </a:defRPr>
+            </a:pPr>
+            <a:r>
+              <a:t>     Comprehensive final project defense before the examination board.</a:t>
+            </a:r>
+          </a:p>
+          <a:p>
+            <a:pPr>
+              <a:spcBef>
+                <a:spcPts val="300"/>
+              </a:spcBef>
+              <a:defRPr sz="880" b="1">
+                <a:solidFill>
+                  <a:srgbClr val="7C3AED"/>
+                </a:solidFill>
+              </a:defRPr>
+            </a:pPr>
+            <a:r>
+              <a:t>★  [30.10.2026]  Final Report Submission ★</a:t>
+            </a:r>
+          </a:p>
+          <a:p>
+            <a:pPr>
+              <a:spcBef>
+                <a:spcPts val="100"/>
+              </a:spcBef>
+              <a:defRPr sz="800">
+                <a:solidFill>
+                  <a:srgbClr val="334155"/>
+                </a:solidFill>
+              </a:defRPr>
+            </a:pPr>
+            <a:r>
+              <a:t>     Submission of finalized documentation, technical report, and source code.</a:t>
+            </a:r>
+          </a:p>
+        </p:txBody>
+      </p:sp>
     </p:spTree>
   </p:cSld>
   <p:clrMapOvr>
@@ -10448,7 +10292,7 @@
               </a:defRPr>
             </a:pPr>
             <a:r>
-              <a:t>Calibrated soft-voting classification</a:t>
+              <a:t>Proposed Calibrated Soft-Voting Ensemble</a:t>
             </a:r>
           </a:p>
         </p:txBody>
@@ -10907,7 +10751,7 @@
                   <a:srgbClr val="334155"/>
                 </a:solidFill>
               </a:rPr>
-              <a:t>Synthesizes calibrated class probability distributions across all candidate models to mitigate individual classifier bias and reduce variance.</a:t>
+              <a:t>Synthesizes average probability distributions across candidate models to mitigate individual classifier bias and reduce variance.</a:t>
             </a:r>
           </a:p>
           <a:p>
@@ -11530,7 +11374,7 @@
               </a:defRPr>
             </a:pPr>
             <a:r>
-              <a:t>High variance &amp; heavy GPU requirements</a:t>
+              <a:t>High compute requirements &amp; model variance</a:t>
             </a:r>
           </a:p>
         </p:txBody>
@@ -11751,46 +11595,46 @@
           <a:p>
             <a:pPr>
               <a:spcBef>
-                <a:spcPts val="300"/>
+                <a:spcPts val="400"/>
               </a:spcBef>
-              <a:defRPr sz="900">
+              <a:defRPr sz="960">
                 <a:solidFill>
                   <a:srgbClr val="334155"/>
                 </a:solidFill>
               </a:defRPr>
             </a:pPr>
             <a:r>
-              <a:t>•  Medical text contains distinct lexical noise: contractions, special characters, and non-informative clinical stops.</a:t>
+              <a:t>•  Clinical narratives contain abbreviations, punctuation noise, and non-standard doctor shorthand.</a:t>
             </a:r>
           </a:p>
           <a:p>
             <a:pPr>
               <a:spcBef>
-                <a:spcPts val="300"/>
+                <a:spcPts val="400"/>
               </a:spcBef>
-              <a:defRPr sz="900">
+              <a:defRPr sz="960">
                 <a:solidFill>
                   <a:srgbClr val="334155"/>
                 </a:solidFill>
               </a:defRPr>
             </a:pPr>
             <a:r>
-              <a:t>•  Studies establish a standard 5-step sequence: Cleaning, Lowercasing, Stop-word removal, Lemmatization, and Tokenization.</a:t>
+              <a:t>•  Implements a 5-step sequence: Cleaning, Lowercasing, Tokenization, Stop-word removal, and Lemmatization.</a:t>
             </a:r>
           </a:p>
           <a:p>
             <a:pPr>
               <a:spcBef>
-                <a:spcPts val="300"/>
+                <a:spcPts val="400"/>
               </a:spcBef>
-              <a:defRPr sz="900">
+              <a:defRPr sz="960">
                 <a:solidFill>
                   <a:srgbClr val="334155"/>
                 </a:solidFill>
               </a:defRPr>
             </a:pPr>
             <a:r>
-              <a:t>•  Domain-specific lemmatization normalizes inflected clinical roots without losing diagnostic context.</a:t>
+              <a:t>•  Morphological lemmatization normalizes inflected clinical terms while preserving diagnostic root semantics.</a:t>
             </a:r>
           </a:p>
         </p:txBody>
@@ -11919,46 +11763,46 @@
           <a:p>
             <a:pPr>
               <a:spcBef>
-                <a:spcPts val="300"/>
+                <a:spcPts val="400"/>
               </a:spcBef>
-              <a:defRPr sz="900">
+              <a:defRPr sz="960">
                 <a:solidFill>
                   <a:srgbClr val="334155"/>
                 </a:solidFill>
               </a:defRPr>
             </a:pPr>
             <a:r>
-              <a:t>•  Clinical notes exhibit high dimensional vocabulary with extreme word frequency variance across specialties.</a:t>
+              <a:t>•  Converts unstructured medical text into standardized, high-dimensional sparse numerical feature vectors.</a:t>
             </a:r>
           </a:p>
           <a:p>
             <a:pPr>
               <a:spcBef>
-                <a:spcPts val="300"/>
+                <a:spcPts val="400"/>
               </a:spcBef>
-              <a:defRPr sz="900">
+              <a:defRPr sz="960">
                 <a:solidFill>
                   <a:srgbClr val="334155"/>
                 </a:solidFill>
               </a:defRPr>
             </a:pPr>
             <a:r>
-              <a:t>•  TF-IDF with sublinear scaling (1 + log(TF)) dampens repetitive clinical terms ('patient', 'procedure').</a:t>
+              <a:t>•  Sublinear scaling (1 + log(TF)) dampens repetitive non-informative terms while highlighting discriminative tokens.</a:t>
             </a:r>
           </a:p>
           <a:p>
             <a:pPr>
               <a:spcBef>
-                <a:spcPts val="300"/>
+                <a:spcPts val="400"/>
               </a:spcBef>
-              <a:defRPr sz="900">
+              <a:defRPr sz="960">
                 <a:solidFill>
                   <a:srgbClr val="334155"/>
                 </a:solidFill>
               </a:defRPr>
             </a:pPr>
             <a:r>
-              <a:t>•  Significantly faster and more lightweight than Word2Vec or deep embeddings, enabling instant local web deployment.</a:t>
+              <a:t>•  Computationally lightweight; enables rapid CPU-based real-time inference on web platforms.</a:t>
             </a:r>
           </a:p>
         </p:txBody>
@@ -12087,46 +11931,46 @@
           <a:p>
             <a:pPr>
               <a:spcBef>
-                <a:spcPts val="300"/>
+                <a:spcPts val="400"/>
               </a:spcBef>
-              <a:defRPr sz="900">
+              <a:defRPr sz="960">
                 <a:solidFill>
                   <a:srgbClr val="334155"/>
                 </a:solidFill>
               </a:defRPr>
             </a:pPr>
             <a:r>
-              <a:t>•  Literature demonstrates that SVM and Logistic Regression excel at high-dimensional sparse text vectors.</a:t>
+              <a:t>•  Linear models (SVM, Logistic Regression) excel on high-dimensional sparse text representations.</a:t>
             </a:r>
           </a:p>
           <a:p>
             <a:pPr>
               <a:spcBef>
-                <a:spcPts val="300"/>
+                <a:spcPts val="400"/>
               </a:spcBef>
-              <a:defRPr sz="900">
+              <a:defRPr sz="960">
                 <a:solidFill>
                   <a:srgbClr val="334155"/>
                 </a:solidFill>
               </a:defRPr>
             </a:pPr>
             <a:r>
-              <a:t>•  Random Forest introduces non-linear feature interactions and bagging robustness.</a:t>
+              <a:t>•  Random Forest introduces non-linear decision partitioning and bagging variance reduction.</a:t>
             </a:r>
           </a:p>
           <a:p>
             <a:pPr>
               <a:spcBef>
-                <a:spcPts val="300"/>
+                <a:spcPts val="400"/>
               </a:spcBef>
-              <a:defRPr sz="900">
+              <a:defRPr sz="960">
                 <a:solidFill>
                   <a:srgbClr val="334155"/>
                 </a:solidFill>
               </a:defRPr>
             </a:pPr>
             <a:r>
-              <a:t>•  Multinomial Naive Bayes provides strong, rapid probabilistic likelihoods for word frequency text representations.</a:t>
+              <a:t>•  Multinomial Naive Bayes provides fast, effective probabilistic likelihood estimation for text vectors.</a:t>
             </a:r>
           </a:p>
         </p:txBody>
@@ -12255,46 +12099,46 @@
           <a:p>
             <a:pPr>
               <a:spcBef>
-                <a:spcPts val="300"/>
+                <a:spcPts val="400"/>
               </a:spcBef>
-              <a:defRPr sz="900">
+              <a:defRPr sz="960">
                 <a:solidFill>
                   <a:srgbClr val="334155"/>
                 </a:solidFill>
               </a:defRPr>
             </a:pPr>
             <a:r>
-              <a:t>•  Individual models show variable recall across the 40 imbalanced medical specialties in clinical practice.</a:t>
+              <a:t>•  Identified Gap: Many deep learning approaches demand heavy GPU resources, while single models show variance on rare specialties.</a:t>
             </a:r>
           </a:p>
           <a:p>
             <a:pPr>
               <a:spcBef>
-                <a:spcPts val="300"/>
+                <a:spcPts val="400"/>
               </a:spcBef>
-              <a:defRPr sz="900">
+              <a:defRPr sz="960">
                 <a:solidFill>
                   <a:srgbClr val="334155"/>
                 </a:solidFill>
               </a:defRPr>
             </a:pPr>
             <a:r>
-              <a:t>•  Deep transformer models (BioBERT) require heavy GPU servers, unsuitable for lightweight hospital web apps.</a:t>
+              <a:t>•  Proposed Solution: An accessible Soft Voting Ensemble combining calibrated base models for balanced classification.</a:t>
             </a:r>
           </a:p>
           <a:p>
             <a:pPr>
               <a:spcBef>
-                <a:spcPts val="300"/>
+                <a:spcPts val="400"/>
               </a:spcBef>
-              <a:defRPr sz="900">
+              <a:defRPr sz="960">
                 <a:solidFill>
                   <a:srgbClr val="334155"/>
                 </a:solidFill>
               </a:defRPr>
             </a:pPr>
             <a:r>
-              <a:t>•  Research Gap: Need for a fast, accessible Soft Voting Ensemble combining calibrated base estimators.</a:t>
+              <a:t>•  Practical Outcome: Achieves robust multi-class accuracy across all 40 specialties on standard CPU hardware.</a:t>
             </a:r>
           </a:p>
         </p:txBody>
@@ -12719,8 +12563,8 @@
         </p:nvSpPr>
         <p:spPr>
           <a:xfrm>
-            <a:off x="914400" y="1389888"/>
-            <a:ext cx="3063240" cy="4617720"/>
+            <a:off x="914400" y="1371600"/>
+            <a:ext cx="3063240" cy="4645152"/>
           </a:xfrm>
           <a:prstGeom prst="rect">
             <a:avLst/>
@@ -12749,14 +12593,44 @@
               <a:spcBef>
                 <a:spcPts val="200"/>
               </a:spcBef>
-              <a:defRPr sz="1200" b="1">
+              <a:defRPr sz="1080" b="1">
                 <a:solidFill>
                   <a:srgbClr val="0F172A"/>
                 </a:solidFill>
               </a:defRPr>
             </a:pPr>
             <a:r>
-              <a:t>Clinical Text Classification using Machine Learning</a:t>
+              <a:t>Clinical Text Classification with Word Representation Features and Machine Learning</a:t>
+            </a:r>
+          </a:p>
+          <a:p>
+            <a:pPr>
+              <a:spcBef>
+                <a:spcPts val="300"/>
+              </a:spcBef>
+              <a:defRPr sz="900">
+                <a:solidFill>
+                  <a:srgbClr val="64748B"/>
+                </a:solidFill>
+              </a:defRPr>
+            </a:pPr>
+            <a:r>
+              <a:t>Authors: Omar AM, Elhoseny M, Hassanien AM (2023)</a:t>
+            </a:r>
+          </a:p>
+          <a:p>
+            <a:pPr>
+              <a:spcBef>
+                <a:spcPts val="1000"/>
+              </a:spcBef>
+              <a:defRPr sz="950" b="1">
+                <a:solidFill>
+                  <a:srgbClr val="1D4ED8"/>
+                </a:solidFill>
+              </a:defRPr>
+            </a:pPr>
+            <a:r>
+              <a:t>METHODOLOGY &amp; DATASET:</a:t>
             </a:r>
           </a:p>
           <a:p>
@@ -12764,14 +12638,14 @@
               <a:spcBef>
                 <a:spcPts val="200"/>
               </a:spcBef>
-              <a:defRPr sz="950">
-                <a:solidFill>
-                  <a:srgbClr val="64748B"/>
-                </a:solidFill>
-              </a:defRPr>
-            </a:pPr>
-            <a:r>
-              <a:t>Authors: Almazaydeh et al. (2023)</a:t>
+              <a:defRPr sz="919">
+                <a:solidFill>
+                  <a:srgbClr val="334155"/>
+                </a:solidFill>
+              </a:defRPr>
+            </a:pPr>
+            <a:r>
+              <a:t>EMR Clinical Transcriptions | Evaluated BOW, TF-IDF, and Word2Vec across LR, SVM, Naive Bayes, and k-NN.</a:t>
             </a:r>
           </a:p>
           <a:p>
@@ -12779,14 +12653,14 @@
               <a:spcBef>
                 <a:spcPts val="1000"/>
               </a:spcBef>
-              <a:defRPr sz="900" b="1">
-                <a:solidFill>
-                  <a:srgbClr val="1D4ED8"/>
-                </a:solidFill>
-              </a:defRPr>
-            </a:pPr>
-            <a:r>
-              <a:t>METHODOLOGY &amp; DATASET:</a:t>
+              <a:defRPr sz="950" b="1">
+                <a:solidFill>
+                  <a:srgbClr val="0D9488"/>
+                </a:solidFill>
+              </a:defRPr>
+            </a:pPr>
+            <a:r>
+              <a:t>KEY RESEARCH FINDING:</a:t>
             </a:r>
           </a:p>
           <a:p>
@@ -12794,14 +12668,14 @@
               <a:spcBef>
                 <a:spcPts val="200"/>
               </a:spcBef>
-              <a:defRPr sz="900">
+              <a:defRPr sz="919">
                 <a:solidFill>
                   <a:srgbClr val="334155"/>
                 </a:solidFill>
               </a:defRPr>
             </a:pPr>
             <a:r>
-              <a:t>Kaggle MTSamples Dataset | 5-Stage Modular NLP Pipeline (Cleaning, Lowering, Stop-words, Lemmatization, Tokenization) + TF-IDF Vectorization.</a:t>
+              <a:t>Linear classifiers and SVM proved highly effective and computationally efficient on high-dimensional text vectors.</a:t>
             </a:r>
           </a:p>
           <a:p>
@@ -12809,14 +12683,14 @@
               <a:spcBef>
                 <a:spcPts val="1000"/>
               </a:spcBef>
-              <a:defRPr sz="900" b="1">
-                <a:solidFill>
-                  <a:srgbClr val="0D9488"/>
-                </a:solidFill>
-              </a:defRPr>
-            </a:pPr>
-            <a:r>
-              <a:t>KEY RESEARCH FINDING:</a:t>
+              <a:defRPr sz="950" b="1">
+                <a:solidFill>
+                  <a:srgbClr val="7C3AED"/>
+                </a:solidFill>
+              </a:defRPr>
+            </a:pPr>
+            <a:r>
+              <a:t>DIRECT RELEVANCE TO OUR SYSTEM:</a:t>
             </a:r>
           </a:p>
           <a:p>
@@ -12824,44 +12698,14 @@
               <a:spcBef>
                 <a:spcPts val="200"/>
               </a:spcBef>
-              <a:defRPr sz="900">
+              <a:defRPr sz="919">
                 <a:solidFill>
                   <a:srgbClr val="334155"/>
                 </a:solidFill>
               </a:defRPr>
             </a:pPr>
             <a:r>
-              <a:t>Demonstrated that thorough clinical text preprocessing and TF-IDF feature weighting are critical to prevent sparse lexical noise and boost classification accuracy.</a:t>
-            </a:r>
-          </a:p>
-          <a:p>
-            <a:pPr>
-              <a:spcBef>
-                <a:spcPts val="1000"/>
-              </a:spcBef>
-              <a:defRPr sz="900" b="1">
-                <a:solidFill>
-                  <a:srgbClr val="7C3AED"/>
-                </a:solidFill>
-              </a:defRPr>
-            </a:pPr>
-            <a:r>
-              <a:t>DIRECT RELEVANCE TO OUR SYSTEM:</a:t>
-            </a:r>
-          </a:p>
-          <a:p>
-            <a:pPr>
-              <a:spcBef>
-                <a:spcPts val="200"/>
-              </a:spcBef>
-              <a:defRPr sz="900">
-                <a:solidFill>
-                  <a:srgbClr val="334155"/>
-                </a:solidFill>
-              </a:defRPr>
-            </a:pPr>
-            <a:r>
-              <a:t>Establishes our exact 5-step NLP preprocessing pipeline and proves the efficacy of the public Kaggle MTSamples benchmark dataset.</a:t>
+              <a:t>Establishes our multi-phase text preprocessing and TF-IDF feature representation pipeline.</a:t>
             </a:r>
           </a:p>
         </p:txBody>
@@ -12962,8 +12806,8 @@
         </p:nvSpPr>
         <p:spPr>
           <a:xfrm>
-            <a:off x="4562856" y="1389888"/>
-            <a:ext cx="3063240" cy="4617720"/>
+            <a:off x="4562856" y="1371600"/>
+            <a:ext cx="3063240" cy="4645152"/>
           </a:xfrm>
           <a:prstGeom prst="rect">
             <a:avLst/>
@@ -12992,14 +12836,44 @@
               <a:spcBef>
                 <a:spcPts val="200"/>
               </a:spcBef>
-              <a:defRPr sz="1200" b="1">
+              <a:defRPr sz="1080" b="1">
                 <a:solidFill>
                   <a:srgbClr val="0F172A"/>
                 </a:solidFill>
               </a:defRPr>
             </a:pPr>
             <a:r>
-              <a:t>Clinical Vectorization and Multi-Class Supervised Learning</a:t>
+              <a:t>Medical Specialty Classification Based on Semiadversarial Data Augmentation</a:t>
+            </a:r>
+          </a:p>
+          <a:p>
+            <a:pPr>
+              <a:spcBef>
+                <a:spcPts val="300"/>
+              </a:spcBef>
+              <a:defRPr sz="900">
+                <a:solidFill>
+                  <a:srgbClr val="64748B"/>
+                </a:solidFill>
+              </a:defRPr>
+            </a:pPr>
+            <a:r>
+              <a:t>Authors: Zhang H, Zhu D, Tan H, Shafiq M, Gu Z (2023)</a:t>
+            </a:r>
+          </a:p>
+          <a:p>
+            <a:pPr>
+              <a:spcBef>
+                <a:spcPts val="1000"/>
+              </a:spcBef>
+              <a:defRPr sz="950" b="1">
+                <a:solidFill>
+                  <a:srgbClr val="1D4ED8"/>
+                </a:solidFill>
+              </a:defRPr>
+            </a:pPr>
+            <a:r>
+              <a:t>METHODOLOGY &amp; DATASET:</a:t>
             </a:r>
           </a:p>
           <a:p>
@@ -13007,14 +12881,14 @@
               <a:spcBef>
                 <a:spcPts val="200"/>
               </a:spcBef>
-              <a:defRPr sz="950">
-                <a:solidFill>
-                  <a:srgbClr val="64748B"/>
-                </a:solidFill>
-              </a:defRPr>
-            </a:pPr>
-            <a:r>
-              <a:t>Authors: Omar et al. (2023)</a:t>
+              <a:defRPr sz="919">
+                <a:solidFill>
+                  <a:srgbClr val="334155"/>
+                </a:solidFill>
+              </a:defRPr>
+            </a:pPr>
+            <a:r>
+              <a:t>Kaggle Medical Specialty Dataset | Evaluated domain noun weighting and feature representations across specialty classes.</a:t>
             </a:r>
           </a:p>
           <a:p>
@@ -13022,14 +12896,14 @@
               <a:spcBef>
                 <a:spcPts val="1000"/>
               </a:spcBef>
-              <a:defRPr sz="900" b="1">
-                <a:solidFill>
-                  <a:srgbClr val="1D4ED8"/>
-                </a:solidFill>
-              </a:defRPr>
-            </a:pPr>
-            <a:r>
-              <a:t>METHODOLOGY &amp; DATASET:</a:t>
+              <a:defRPr sz="950" b="1">
+                <a:solidFill>
+                  <a:srgbClr val="0D9488"/>
+                </a:solidFill>
+              </a:defRPr>
+            </a:pPr>
+            <a:r>
+              <a:t>KEY RESEARCH FINDING:</a:t>
             </a:r>
           </a:p>
           <a:p>
@@ -13037,14 +12911,14 @@
               <a:spcBef>
                 <a:spcPts val="200"/>
               </a:spcBef>
-              <a:defRPr sz="900">
+              <a:defRPr sz="919">
                 <a:solidFill>
                   <a:srgbClr val="334155"/>
                 </a:solidFill>
               </a:defRPr>
             </a:pPr>
             <a:r>
-              <a:t>EMR Narrative Records | Evaluated Logistic Regression, SVM, Multinomial Naive Bayes, and k-NN across clinical categories.</a:t>
+              <a:t>Domain-specific medical nouns carry the strongest discriminative signal for specialty categorization.</a:t>
             </a:r>
           </a:p>
           <a:p>
@@ -13052,14 +12926,14 @@
               <a:spcBef>
                 <a:spcPts val="1000"/>
               </a:spcBef>
-              <a:defRPr sz="900" b="1">
-                <a:solidFill>
-                  <a:srgbClr val="0D9488"/>
-                </a:solidFill>
-              </a:defRPr>
-            </a:pPr>
-            <a:r>
-              <a:t>KEY RESEARCH FINDING:</a:t>
+              <a:defRPr sz="950" b="1">
+                <a:solidFill>
+                  <a:srgbClr val="7C3AED"/>
+                </a:solidFill>
+              </a:defRPr>
+            </a:pPr>
+            <a:r>
+              <a:t>DIRECT RELEVANCE TO OUR SYSTEM:</a:t>
             </a:r>
           </a:p>
           <a:p>
@@ -13067,44 +12941,14 @@
               <a:spcBef>
                 <a:spcPts val="200"/>
               </a:spcBef>
-              <a:defRPr sz="900">
+              <a:defRPr sz="919">
                 <a:solidFill>
                   <a:srgbClr val="334155"/>
                 </a:solidFill>
               </a:defRPr>
             </a:pPr>
             <a:r>
-              <a:t>SVM and Logistic Regression outperformed complex non-linear models on high-dimensional text vectors, achieving peak accuracy (92%) with rapid convergence.</a:t>
-            </a:r>
-          </a:p>
-          <a:p>
-            <a:pPr>
-              <a:spcBef>
-                <a:spcPts val="1000"/>
-              </a:spcBef>
-              <a:defRPr sz="900" b="1">
-                <a:solidFill>
-                  <a:srgbClr val="7C3AED"/>
-                </a:solidFill>
-              </a:defRPr>
-            </a:pPr>
-            <a:r>
-              <a:t>DIRECT RELEVANCE TO OUR SYSTEM:</a:t>
-            </a:r>
-          </a:p>
-          <a:p>
-            <a:pPr>
-              <a:spcBef>
-                <a:spcPts val="200"/>
-              </a:spcBef>
-              <a:defRPr sz="900">
-                <a:solidFill>
-                  <a:srgbClr val="334155"/>
-                </a:solidFill>
-              </a:defRPr>
-            </a:pPr>
-            <a:r>
-              <a:t>Directly justifies our selection of SVM and Logistic Regression as core candidate estimators for sparse TF-IDF text matrices.</a:t>
+              <a:t>Highlights class imbalance in MTSamples; motivates an accessible TF-IDF ensemble for all 40 classes on standard CPUs.</a:t>
             </a:r>
           </a:p>
         </p:txBody>
@@ -13205,8 +13049,8 @@
         </p:nvSpPr>
         <p:spPr>
           <a:xfrm>
-            <a:off x="8211312" y="1389888"/>
-            <a:ext cx="3063240" cy="4617720"/>
+            <a:off x="8211312" y="1371600"/>
+            <a:ext cx="3063240" cy="4645152"/>
           </a:xfrm>
           <a:prstGeom prst="rect">
             <a:avLst/>
@@ -13235,14 +13079,44 @@
               <a:spcBef>
                 <a:spcPts val="200"/>
               </a:spcBef>
-              <a:defRPr sz="1200" b="1">
+              <a:defRPr sz="1080" b="1">
                 <a:solidFill>
                   <a:srgbClr val="0F172A"/>
                 </a:solidFill>
               </a:defRPr>
             </a:pPr>
             <a:r>
-              <a:t>Medical Subdomain Classification &amp; Ensemble Aggregation</a:t>
+              <a:t>A Keyword-Enhanced Approach to Handle Class Imbalance in Clinical Text</a:t>
+            </a:r>
+          </a:p>
+          <a:p>
+            <a:pPr>
+              <a:spcBef>
+                <a:spcPts val="300"/>
+              </a:spcBef>
+              <a:defRPr sz="900">
+                <a:solidFill>
+                  <a:srgbClr val="64748B"/>
+                </a:solidFill>
+              </a:defRPr>
+            </a:pPr>
+            <a:r>
+              <a:t>Authors: Blanchard AE, Gao S, Yoon HJ, Tourassi G (2022)</a:t>
+            </a:r>
+          </a:p>
+          <a:p>
+            <a:pPr>
+              <a:spcBef>
+                <a:spcPts val="1000"/>
+              </a:spcBef>
+              <a:defRPr sz="950" b="1">
+                <a:solidFill>
+                  <a:srgbClr val="1D4ED8"/>
+                </a:solidFill>
+              </a:defRPr>
+            </a:pPr>
+            <a:r>
+              <a:t>METHODOLOGY &amp; DATASET:</a:t>
             </a:r>
           </a:p>
           <a:p>
@@ -13250,14 +13124,14 @@
               <a:spcBef>
                 <a:spcPts val="200"/>
               </a:spcBef>
-              <a:defRPr sz="950">
-                <a:solidFill>
-                  <a:srgbClr val="64748B"/>
-                </a:solidFill>
-              </a:defRPr>
-            </a:pPr>
-            <a:r>
-              <a:t>Authors: Weng et al. (2017) / Al-Garadi et al.</a:t>
+              <a:defRPr sz="919">
+                <a:solidFill>
+                  <a:srgbClr val="334155"/>
+                </a:solidFill>
+              </a:defRPr>
+            </a:pPr>
+            <a:r>
+              <a:t>Clinical Pathology Reports | Evaluated keyword-constrained weighting on imbalanced clinical narratives.</a:t>
             </a:r>
           </a:p>
           <a:p>
@@ -13265,14 +13139,14 @@
               <a:spcBef>
                 <a:spcPts val="1000"/>
               </a:spcBef>
-              <a:defRPr sz="900" b="1">
-                <a:solidFill>
-                  <a:srgbClr val="1D4ED8"/>
-                </a:solidFill>
-              </a:defRPr>
-            </a:pPr>
-            <a:r>
-              <a:t>METHODOLOGY &amp; DATASET:</a:t>
+              <a:defRPr sz="950" b="1">
+                <a:solidFill>
+                  <a:srgbClr val="0D9488"/>
+                </a:solidFill>
+              </a:defRPr>
+            </a:pPr>
+            <a:r>
+              <a:t>KEY RESEARCH FINDING:</a:t>
             </a:r>
           </a:p>
           <a:p>
@@ -13280,14 +13154,14 @@
               <a:spcBef>
                 <a:spcPts val="200"/>
               </a:spcBef>
-              <a:defRPr sz="900">
+              <a:defRPr sz="919">
                 <a:solidFill>
                   <a:srgbClr val="334155"/>
                 </a:solidFill>
               </a:defRPr>
             </a:pPr>
             <a:r>
-              <a:t>Multi-Specialty Clinical Narratives | Multi-estimator aggregation, probability consensus, and tree-based decision ensembles.</a:t>
+              <a:t>Targeted keyword features improved classification on minority classes without degrading majority performance.</a:t>
             </a:r>
           </a:p>
           <a:p>
@@ -13295,14 +13169,14 @@
               <a:spcBef>
                 <a:spcPts val="1000"/>
               </a:spcBef>
-              <a:defRPr sz="900" b="1">
-                <a:solidFill>
-                  <a:srgbClr val="0D9488"/>
-                </a:solidFill>
-              </a:defRPr>
-            </a:pPr>
-            <a:r>
-              <a:t>KEY RESEARCH FINDING:</a:t>
+              <a:defRPr sz="950" b="1">
+                <a:solidFill>
+                  <a:srgbClr val="7C3AED"/>
+                </a:solidFill>
+              </a:defRPr>
+            </a:pPr>
+            <a:r>
+              <a:t>DIRECT RELEVANCE TO OUR SYSTEM:</a:t>
             </a:r>
           </a:p>
           <a:p>
@@ -13310,44 +13184,14 @@
               <a:spcBef>
                 <a:spcPts val="200"/>
               </a:spcBef>
-              <a:defRPr sz="900">
+              <a:defRPr sz="919">
                 <a:solidFill>
                   <a:srgbClr val="334155"/>
                 </a:solidFill>
               </a:defRPr>
             </a:pPr>
             <a:r>
-              <a:t>Ensemble voting across complementary classifiers significantly mitigates individual estimator variance and improves multi-class minority specialty recognition.</a:t>
-            </a:r>
-          </a:p>
-          <a:p>
-            <a:pPr>
-              <a:spcBef>
-                <a:spcPts val="1000"/>
-              </a:spcBef>
-              <a:defRPr sz="900" b="1">
-                <a:solidFill>
-                  <a:srgbClr val="7C3AED"/>
-                </a:solidFill>
-              </a:defRPr>
-            </a:pPr>
-            <a:r>
-              <a:t>DIRECT RELEVANCE TO OUR SYSTEM:</a:t>
-            </a:r>
-          </a:p>
-          <a:p>
-            <a:pPr>
-              <a:spcBef>
-                <a:spcPts val="200"/>
-              </a:spcBef>
-              <a:defRPr sz="900">
-                <a:solidFill>
-                  <a:srgbClr val="334155"/>
-                </a:solidFill>
-              </a:defRPr>
-            </a:pPr>
-            <a:r>
-              <a:t>Provides the foundational justification for our proposed Soft Consensus Voting Ensemble combining SVM, Random Forest, LR, and MNB.</a:t>
+              <a:t>Confirms n-gram keyword weighting preserves rare specialty signals, justifying TF-IDF and stratified evaluation.</a:t>
             </a:r>
           </a:p>
         </p:txBody>
@@ -14354,7 +14198,7 @@
               </a:defRPr>
             </a:pPr>
             <a:r>
-              <a:t>•  Public Academic Benchmark: </a:t>
+              <a:t>•  Public Benchmark Dataset: </a:t>
             </a:r>
             <a:r>
               <a:rPr b="0" sz="900">
@@ -14362,7 +14206,7 @@
                   <a:srgbClr val="334155"/>
                 </a:solidFill>
               </a:rPr>
-              <a:t>Sourced from the verified Kaggle MTSamples repository, comprising real-world anonymized medical transcription dictations.</a:t>
+              <a:t>The MTSamples dataset is a publicly available collection of medical transcription samples commonly used for text classification research.</a:t>
             </a:r>
           </a:p>
           <a:p>
@@ -14377,7 +14221,7 @@
               </a:defRPr>
             </a:pPr>
             <a:r>
-              <a:t>•  Overcoming HIPAA Constraints: </a:t>
+              <a:t>•  Privacy Consideration: </a:t>
             </a:r>
             <a:r>
               <a:rPr b="0" sz="900">
@@ -14385,7 +14229,7 @@
                   <a:srgbClr val="334155"/>
                 </a:solidFill>
               </a:rPr>
-              <a:t>HIPAA privacy regulations legally restrict distribution of private hospital electronic health records (EHR). MTSamples provides an authentic, ethically validated substitute.</a:t>
+              <a:t>Enables machine learning experimentation on realistic clinical narratives without requiring access to private hospital records.</a:t>
             </a:r>
           </a:p>
           <a:p>
@@ -16380,7 +16224,7 @@
               </a:defRPr>
             </a:pPr>
             <a:r>
-              <a:t>•  Impact on Feature Space: Extreme length disparity necessitates L2 Euclidean vector normalization in TF-IDF.</a:t>
+              <a:t>•  Impact on Feature Representation: Variation in document length supports the use of normalized TF-IDF representations to reduce the influence of document magnitude on feature comparison.</a:t>
             </a:r>
           </a:p>
         </p:txBody>
@@ -16475,7 +16319,7 @@
               </a:defRPr>
             </a:pPr>
             <a:r>
-              <a:t>•  Dominant Clinical Jargon: Pervasive occurrences of terms like 'patient', 'procedure', 'history', 'diagnosis', 'left', 'right'.</a:t>
+              <a:t>•  Dominant Clinical Jargon: Pervasive occurrences of clinical terms like 'patient', 'procedure', 'history', 'diagnosis', 'left', 'right'.</a:t>
             </a:r>
           </a:p>
           <a:p>
@@ -16490,7 +16334,22 @@
               </a:defRPr>
             </a:pPr>
             <a:r>
-              <a:t>•  Stop-word Removal &amp; Sublinear Scaling: Validates removing non-discriminative medical stopwords and applying sublinear term frequency weighting.</a:t>
+              <a:t>•  Stop-word Handling: Common non-informative words are removed during preprocessing while preserving clinically meaningful terminology.</a:t>
+            </a:r>
+          </a:p>
+          <a:p>
+            <a:pPr>
+              <a:spcBef>
+                <a:spcPts val="300"/>
+              </a:spcBef>
+              <a:defRPr sz="880">
+                <a:solidFill>
+                  <a:srgbClr val="334155"/>
+                </a:solidFill>
+              </a:defRPr>
+            </a:pPr>
+            <a:r>
+              <a:t>•  Sublinear Term Frequency: Sublinear scaling (1 + log(TF)) dampens repetitive non-informative terms to highlight discriminative features.</a:t>
             </a:r>
           </a:p>
         </p:txBody>
@@ -17025,7 +16884,7 @@
               </a:defRPr>
             </a:pPr>
             <a:r>
-              <a:t>•  Operational vs Diagnostic Depth: </a:t>
+              <a:t>•  Procedural vs Diagnostic Documentation: </a:t>
             </a:r>
             <a:r>
               <a:rPr b="0" sz="880">

</xml_diff>